<commit_message>
docs: deck v2 - 4 levels, n8n+Telegram family loop, passkeys, replay sim, free stack (D-009)
Co-Authored-By: Claude Opus 5.5 <noreply@anthropic.com>
Claude-Session: https://claude.ai/code/session_01PNHy9iYRYYE3fGPSXq8UV9
</commit_message>
<xml_diff>
--- a/docs/05-pitch/Pramaan_BIOS_Screening.pptx
+++ b/docs/05-pitch/Pramaan_BIOS_Screening.pptx
@@ -458,7 +458,7 @@
           <a:lstStyle/>
           <a:p>
             <a:r>
-              <a:t>Our solution is Pramaan, which means proof. It's a cloud risk API that a bank or UPI app calls just before the PIN or OTP step. It scores more than 20 signals against the user's own history and returns allow, challenge or block in milliseconds, with reasons in plain language. Two things make it different. First, thresholds depend on the amount: a 40-rupee tea is never stopped, an 85,000-rupee first-time transfer is checked closely. Second, the challenge depends on the kind of risk. Look at the same 85,000-rupee payment in four situations. Usual payee, own phone: allowed. New phone and a SIM swap yesterday: that's an impostor, so we ask for the owner's fingerprint. Own phone at home, but on a call and pasting a new UPI ID: that's a coached victim. An OTP won't help, so we pause it for 30 minutes and ask a trusted contact. An emulator firing 15 attempts: blocked.</a:t>
+              <a:t>Our solution is Pramaan, which means proof. It's a cloud risk API that a bank or UPI app calls just before the PIN or OTP step. It scores more than 20 signals against the user's own history and returns allow, challenge or block in milliseconds, with reasons in plain language. Two things make it different. First, thresholds depend on the amount: a 40-rupee tea is never stopped, an 85,000-rupee first-time transfer is checked closely. Second, the challenge depends on the kind of risk. Look at the same 85,000-rupee payment in four situations. Usual payee, own phone: allowed. New phone and a SIM swap yesterday: that's an impostor, so we ask for the owner's fingerprint. Own phone at home, but on a call and pasting a new UPI ID: that's a coached victim. An OTP won't help, so we pause it and her son gets an Approve or Cancel message on Telegram. An emulator firing 15 attempts: blocked.</a:t>
             </a:r>
           </a:p>
         </p:txBody>
@@ -544,7 +544,7 @@
           <a:lstStyle/>
           <a:p>
             <a:r>
-              <a:t>Here's how it works. One: the payment app, with our small SDK, sends the transaction, device info and session behaviour, like typing rhythm, time on the confirm screen, a pasted payee, and on mobile whether a call or screen-share is active. Two: our FastAPI service on Cloud Run validates it and starts a timer. Three: we build 20-plus features against this user's own history from a Redis profile store. Four, the risk engine: hard rules first, then a LightGBM model gives a fraud probability, TreeSHAP tells us each signal's contribution, the strongest family tells us the risk type, and a cost policy picks the decision. The thresholds tighten as the amount grows, and the challenge type is whichever costs least for that risk type. Five: allow, challenge or block, plus reasons and latency. If we ever take longer than 150 milliseconds we fall back to standard 2FA, so we never fail open. Everything is logged to Supabase and streamed to a live dashboard. Our training data is synthetic, and we say so: no public dataset has these signals together.</a:t>
+              <a:t>Here's how it works. One: the payment app, with our small SDK, sends the transaction, device info and session behaviour, like typing rhythm, time on the confirm screen, a pasted payee, and on mobile whether a call or screen-share is active. Two: our FastAPI service, on Render's free tier, validates it and starts a timer. Three: we build 20-plus features against this user's own history from an in-memory profile store. Four, the risk engine: hard rules first, then a LightGBM model gives a fraud probability, TreeSHAP tells us each signal's contribution, the strongest family tells us the risk type, and a cost policy picks the decision. The thresholds tighten as the amount grows, and the challenge type is whichever costs least for that risk type. Five: allow, challenge or block, plus reasons and latency. If we ever take longer than 150 milliseconds we fall back to standard 2FA, so we never fail open. For a likely scam, the hold goes to an n8n workflow that messages a family member on Telegram to approve or cancel; for a likely impostor, a passkey fingerprint check. Everything is free and open, so running cost is zero. Our training data is synthetic, and we say so: no public dataset has these signals together.</a:t>
             </a:r>
           </a:p>
         </p:txBody>
@@ -630,7 +630,7 @@
           <a:lstStyle/>
           <a:p>
             <a:r>
-              <a:t>What we'll actually build in the hack: a live authenticate API on Cloud Run, the full risk engine, a demo UPI-style app with our SDK, a live dashboard, and a synthetic dataset with four attack types plus scenario tests and a load test. We're honest about the risks. Our data is synthetic, so we add hard negatives, report metrics per attack type and sanity-check on public datasets. Call and screen-share state needs a mobile SDK, so missing signals count as unknown, never safe. False positives hurt real people, so we only block at very high confidence and keep challenges under five percent. And there's privacy: we store derived features only, under the DPDP Act. Success means catching at least 80 percent of scam-type fraud while challenging at most 5 percent of honest payments, letting 90 percent of honest big transfers through with no delay, and deciding in under 50 milliseconds.</a:t>
+              <a:t>What we'll actually build in the hack: a live authenticate API on a free host, the full risk engine, all four response levels working, including a real passkey fingerprint check and an n8n plus Telegram loop where a family member can cancel a held payment, a dashboard, and a replay simulator comparing us with RBI's blanket delay. All on free tools, zero running cost. We're honest about the risks. Our data is synthetic, so we add hard negatives, report metrics per attack type and sanity-check on public datasets. Call and screen-share state needs a mobile SDK, so missing signals count as unknown, never safe. False positives hurt real people, so we only block at very high confidence and keep challenges under five percent. And there's privacy: we store derived features only, under the DPDP Act. Success means catching at least 80 percent of scam-type fraud while challenging at most 5 percent of honest payments, letting 90 percent of honest big transfers through with no delay, and deciding in under 50 milliseconds.</a:t>
             </a:r>
           </a:p>
         </p:txBody>
@@ -1305,7 +1305,7 @@
                 </a:solidFill>
                 <a:latin typeface="Calibri"/>
               </a:rPr>
-              <a:t>Roll No: ______________</a:t>
+              <a:t>Roll No: 1024030019</a:t>
             </a:r>
           </a:p>
         </p:txBody>
@@ -3113,7 +3113,7 @@
                 </a:solidFill>
                 <a:latin typeface="Calibri"/>
               </a:rPr>
-              <a:t>Typed challenges:</a:t>
+              <a:t>4 levels of response:</a:t>
             </a:r>
             <a:r>
               <a:rPr sz="1250" b="0" i="0">
@@ -3122,7 +3122,7 @@
                 </a:solidFill>
                 <a:latin typeface="Calibri"/>
               </a:rPr>
-              <a:t> biometric for a likely impostor; cooling-off + trusted contact for a likely coached victim</a:t>
+              <a:t> allow · fingerprint for a likely impostor · pause + family approval for a likely scam victim · block</a:t>
             </a:r>
           </a:p>
           <a:p>
@@ -3153,7 +3153,7 @@
                 </a:solidFill>
                 <a:latin typeface="Calibri"/>
               </a:rPr>
-              <a:t>An OTP can't stop someone who is being coached. A pause, a scam-specific warning and a trusted contact can. We use them </a:t>
+              <a:t>An OTP can't stop someone who is being coached. A pause and a family member who can cancel can. We use them </a:t>
             </a:r>
             <a:r>
               <a:rPr sz="1250" b="1" i="0">
@@ -3171,7 +3171,25 @@
                 </a:solidFill>
                 <a:latin typeface="Calibri"/>
               </a:rPr>
-              <a:t> when the context is risky, unlike RBI's proposed blanket 1-hour delay.</a:t>
+              <a:t> when the context is risky, unlike RBI's proposed blanket 1-hour delay. Built on free, open tools: </a:t>
+            </a:r>
+            <a:r>
+              <a:rPr sz="1250" b="1" i="0">
+                <a:solidFill>
+                  <a:srgbClr val="222222"/>
+                </a:solidFill>
+                <a:latin typeface="Calibri"/>
+              </a:rPr>
+              <a:t>₹0 running cost</a:t>
+            </a:r>
+            <a:r>
+              <a:rPr sz="1250" b="0" i="0">
+                <a:solidFill>
+                  <a:srgbClr val="222222"/>
+                </a:solidFill>
+                <a:latin typeface="Calibri"/>
+              </a:rPr>
+              <a:t>.</a:t>
             </a:r>
           </a:p>
         </p:txBody>
@@ -3210,7 +3228,7 @@
                 </a:solidFill>
                 <a:latin typeface="Calibri"/>
               </a:rPr>
-              <a:t>USER INTERACTION: the same ₹85,000 payment, four situations</a:t>
+              <a:t>USER INTERACTION: 4 levels · the same ₹85,000 payment, four situations</a:t>
             </a:r>
           </a:p>
         </p:txBody>
@@ -3326,13 +3344,13 @@
           <a:p>
             <a:pPr algn="ctr"/>
             <a:r>
-              <a:rPr sz="1200" b="1" i="0">
+              <a:rPr sz="1150" b="1" i="0">
                 <a:solidFill>
                   <a:srgbClr val="FFFFFF"/>
                 </a:solidFill>
                 <a:latin typeface="Calibri"/>
               </a:rPr>
-              <a:t>ALLOW</a:t>
+              <a:t>① ALLOW</a:t>
             </a:r>
           </a:p>
         </p:txBody>
@@ -3399,7 +3417,7 @@
                 </a:solidFill>
                 <a:latin typeface="Calibri"/>
               </a:rPr>
-              <a:t>Impostor risk: the owner's fingerprint is needed.</a:t>
+              <a:t>Impostor risk: owner's passkey biometric needed.</a:t>
             </a:r>
           </a:p>
         </p:txBody>
@@ -3448,13 +3466,13 @@
           <a:p>
             <a:pPr algn="ctr"/>
             <a:r>
-              <a:rPr sz="1000" b="1" i="0">
+              <a:rPr sz="1150" b="1" i="0">
                 <a:solidFill>
                   <a:srgbClr val="FFFFFF"/>
                 </a:solidFill>
                 <a:latin typeface="Calibri"/>
               </a:rPr>
-              <a:t>CHALLENGE · biometric</a:t>
+              <a:t>② FINGERPRINT</a:t>
             </a:r>
           </a:p>
         </p:txBody>
@@ -3521,7 +3539,7 @@
                 </a:solidFill>
                 <a:latin typeface="Calibri"/>
               </a:rPr>
-              <a:t>Scam risk: 30-min pause + scam warning</a:t>
+              <a:t>Scam risk: held; son taps Cancel on Telegram</a:t>
             </a:r>
           </a:p>
         </p:txBody>
@@ -3570,13 +3588,13 @@
           <a:p>
             <a:pPr algn="ctr"/>
             <a:r>
-              <a:rPr sz="1000" b="1" i="0">
+              <a:rPr sz="1150" b="1" i="0">
                 <a:solidFill>
                   <a:srgbClr val="FFFFFF"/>
                 </a:solidFill>
                 <a:latin typeface="Calibri"/>
               </a:rPr>
-              <a:t>CHALLENGE · hold + trusted contact</a:t>
+              <a:t>③ PAUSE + FAMILY</a:t>
             </a:r>
           </a:p>
         </p:txBody>
@@ -3692,13 +3710,13 @@
           <a:p>
             <a:pPr algn="ctr"/>
             <a:r>
-              <a:rPr sz="1200" b="1" i="0">
+              <a:rPr sz="1150" b="1" i="0">
                 <a:solidFill>
                   <a:srgbClr val="FFFFFF"/>
                 </a:solidFill>
                 <a:latin typeface="Calibri"/>
               </a:rPr>
-              <a:t>BLOCK</a:t>
+              <a:t>④ BLOCK</a:t>
             </a:r>
           </a:p>
         </p:txBody>
@@ -4099,7 +4117,7 @@
                 </a:solidFill>
                 <a:latin typeface="Calibri"/>
               </a:rPr>
-              <a:t>FastAPI on Cloud Run: validate, start timer. Over 150 ms → falls back to standard 2FA</a:t>
+              <a:t>FastAPI on Render (free tier): validate, start timer. Over 150 ms → falls back to standard 2FA</a:t>
             </a:r>
           </a:p>
         </p:txBody>
@@ -4245,7 +4263,7 @@
                 </a:solidFill>
                 <a:latin typeface="Calibri"/>
               </a:rPr>
-              <a:t>Profile store (Redis)</a:t>
+              <a:t>Profile store (in-memory)</a:t>
             </a:r>
           </a:p>
           <a:p>
@@ -4757,7 +4775,23 @@
                 </a:solidFill>
                 <a:latin typeface="Calibri"/>
               </a:rPr>
-              <a:t>+ score, top-3 reasons, latency, model version</a:t>
+              <a:t>+ score, top-3 reasons, latency</a:t>
+            </a:r>
+          </a:p>
+          <a:p>
+            <a:pPr algn="l">
+              <a:spcBef>
+                <a:spcPts val="300"/>
+              </a:spcBef>
+            </a:pPr>
+            <a:r>
+              <a:rPr sz="1050" b="1" i="0">
+                <a:solidFill>
+                  <a:srgbClr val="1E2761"/>
+                </a:solidFill>
+                <a:latin typeface="Calibri"/>
+              </a:rPr>
+              <a:t>Holds → n8n → family on Telegram</a:t>
             </a:r>
           </a:p>
         </p:txBody>
@@ -5001,7 +5035,7 @@
                 </a:solidFill>
                 <a:latin typeface="Calibri"/>
               </a:rPr>
-              <a:t>SDK + demo app, API, feature builder, rules + LightGBM + TreeSHAP, cost policy, event log, live dashboard, cloud deploy, load test.   </a:t>
+              <a:t>SDK + demo app, API, risk engine, passkey fingerprint, n8n + Telegram family loop, replay simulator, live dashboard, deploy.   </a:t>
             </a:r>
             <a:r>
               <a:rPr sz="1100" b="1" i="0">
@@ -5026,7 +5060,7 @@
       </p:sp>
       <p:sp>
         <p:nvSpPr>
-          <p:cNvPr id="33" name="Panel STACK"/>
+          <p:cNvPr id="33" name="Panel STACK (all free, ₹0 running cost)"/>
           <p:cNvSpPr/>
           <p:nvPr/>
         </p:nvSpPr>
@@ -5078,7 +5112,7 @@
                 </a:solidFill>
                 <a:latin typeface="Calibri"/>
               </a:rPr>
-              <a:t>STACK</a:t>
+              <a:t>STACK (all free, ₹0 running cost)</a:t>
             </a:r>
           </a:p>
           <a:p>
@@ -5098,7 +5132,7 @@
                 </a:solidFill>
                 <a:latin typeface="Calibri"/>
               </a:rPr>
-              <a:t>Python 3.11 · FastAPI · LightGBM · SHAP · Redis</a:t>
+              <a:t>Python · FastAPI · LightGBM · SHAP on Render (no card) · React on Vercel · Supabase free tier</a:t>
             </a:r>
           </a:p>
           <a:p>
@@ -5118,7 +5152,7 @@
                 </a:solidFill>
                 <a:latin typeface="Calibri"/>
               </a:rPr>
-              <a:t>Supabase Postgres (event log, realtime) · React (Vite) on Vercel · Docker → Google Cloud Run</a:t>
+              <a:t>n8n (self-hosted) + Telegram Bot API: hold → family Approve/Cancel → timeout → label</a:t>
             </a:r>
           </a:p>
           <a:p>
@@ -5138,7 +5172,7 @@
                 </a:solidFill>
                 <a:latin typeface="Calibri"/>
               </a:rPr>
-              <a:t>Log → dashboard: live feed, “why” panel, latency, threshold sliders. Feedback API → labels → retrain.</a:t>
+              <a:t>WebAuthn passkeys for fingerprint · replay simulator: our policy vs RBI's blanket delay</a:t>
             </a:r>
           </a:p>
         </p:txBody>
@@ -5759,7 +5793,7 @@
                 </a:solidFill>
                 <a:latin typeface="Calibri"/>
               </a:rPr>
-              <a:t>Live /v1/authenticate on Cloud Run, with fail-safe</a:t>
+              <a:t>Live /v1/authenticate (Render, free) with fail-safe</a:t>
             </a:r>
           </a:p>
           <a:p>
@@ -5779,7 +5813,7 @@
                 </a:solidFill>
                 <a:latin typeface="Calibri"/>
               </a:rPr>
-              <a:t>Rules + LightGBM + TreeSHAP reasons + cost policy</a:t>
+              <a:t>Risk engine: rules + LightGBM + TreeSHAP + cost policy</a:t>
             </a:r>
           </a:p>
           <a:p>
@@ -5799,7 +5833,7 @@
                 </a:solidFill>
                 <a:latin typeface="Calibri"/>
               </a:rPr>
-              <a:t>Demo UPI-style app + JS SDK + scenario toggles</a:t>
+              <a:t>4 levels live: passkey fingerprint, n8n + Telegram family loop</a:t>
             </a:r>
           </a:p>
           <a:p>
@@ -5819,7 +5853,7 @@
                 </a:solidFill>
                 <a:latin typeface="Calibri"/>
               </a:rPr>
-              <a:t>Dashboard: live feed, “why” panel, latency, sliders</a:t>
+              <a:t>Demo UPI app + SDK; dashboard with “why” panel</a:t>
             </a:r>
           </a:p>
           <a:p>
@@ -5839,7 +5873,7 @@
                 </a:solidFill>
                 <a:latin typeface="Calibri"/>
               </a:rPr>
-              <a:t>Synthetic data (4 attack types), scenario tests, load test</a:t>
+              <a:t>Replay simulator vs RBI's blanket delay; synthetic data</a:t>
             </a:r>
           </a:p>
           <a:p>
@@ -5874,7 +5908,7 @@
                 </a:solidFill>
                 <a:latin typeface="Calibri"/>
               </a:rPr>
-              <a:t>H0–6 data + scaffolding · H6–12 engine + API · H8–16 app + dashboard · H12–18 tests + metrics · H18+ deploy + rehearse</a:t>
+              <a:t>H0–6 data + scaffolding · H6–12 engine + API · H8–16 app, passkeys, n8n loop · H12–18 dashboard, simulator, tests · H18+ deploy + rehearse</a:t>
             </a:r>
           </a:p>
           <a:p>
@@ -5886,7 +5920,7 @@
                 </a:solidFill>
                 <a:latin typeface="Calibri"/>
               </a:rPr>
-              <a:t>Owners: </a:t>
+              <a:t>Cost: </a:t>
             </a:r>
             <a:r>
               <a:rPr sz="1100" b="0" i="0">
@@ -5895,7 +5929,7 @@
                 </a:solidFill>
                 <a:latin typeface="Calibri"/>
               </a:rPr>
-              <a:t>Bhavyam API/cloud · Gunagye ML · Abhijay app/SDK · Shefali dashboard/eval</a:t>
+              <a:t>₹0, free tiers + open source, no paid APIs.</a:t>
             </a:r>
           </a:p>
         </p:txBody>

</xml_diff>

<commit_message>
docs: add Bhavyam & Shefali roll numbers to team + deck
Co-Authored-By: Claude Opus 5.5 <noreply@anthropic.com>
Claude-Session: https://claude.ai/code/session_01PNHy9iYRYYE3fGPSXq8UV9
</commit_message>
<xml_diff>
--- a/docs/05-pitch/Pramaan_BIOS_Screening.pptx
+++ b/docs/05-pitch/Pramaan_BIOS_Screening.pptx
@@ -1258,7 +1258,7 @@
                 </a:solidFill>
                 <a:latin typeface="Calibri"/>
               </a:rPr>
-              <a:t>Roll No: ______________</a:t>
+              <a:t>Roll No: 1024030535</a:t>
             </a:r>
           </a:p>
         </p:txBody>
@@ -1399,7 +1399,7 @@
                 </a:solidFill>
                 <a:latin typeface="Calibri"/>
               </a:rPr>
-              <a:t>Roll No: ______________</a:t>
+              <a:t>Roll No: 1024030284</a:t>
             </a:r>
           </a:p>
         </p:txBody>

</xml_diff>

<commit_message>
docs: challenge ID Frontier PS-04 on deck slide 1 and problem statement
Co-Authored-By: Claude Opus 5.5 <noreply@anthropic.com>
Claude-Session: https://claude.ai/code/session_01PNHy9iYRYYE3fGPSXq8UV9
</commit_message>
<xml_diff>
--- a/docs/05-pitch/Pramaan_BIOS_Screening.pptx
+++ b/docs/05-pitch/Pramaan_BIOS_Screening.pptx
@@ -1211,7 +1211,25 @@
                 </a:solidFill>
                 <a:latin typeface="Calibri"/>
               </a:rPr>
-              <a:t>   ·   Frontier · Fast and Secure Online Transaction Authentication   ·   Challenge ID: ________</a:t>
+              <a:t>   ·   Challenge: </a:t>
+            </a:r>
+            <a:r>
+              <a:rPr sz="1100" b="1" i="0">
+                <a:solidFill>
+                  <a:srgbClr val="1E2761"/>
+                </a:solidFill>
+                <a:latin typeface="Calibri"/>
+              </a:rPr>
+              <a:t>Frontier · PS-04</a:t>
+            </a:r>
+            <a:r>
+              <a:rPr sz="1100" b="0" i="0">
+                <a:solidFill>
+                  <a:srgbClr val="1E2761"/>
+                </a:solidFill>
+                <a:latin typeface="Calibri"/>
+              </a:rPr>
+              <a:t> · Fast and Secure Online Transaction Authentication</a:t>
             </a:r>
           </a:p>
         </p:txBody>

</xml_diff>